<commit_message>
feat: enlarge slide diagrams with 6:6 grid, lightbox zoom modal, and updated PPTX
</commit_message>
<xml_diff>
--- a/CICD_Masterclass_20_Slides.pptx
+++ b/CICD_Masterclass_20_Slides.pptx
@@ -4065,7 +4065,7 @@
         <p:spPr>
           <a:xfrm>
             <a:off x="731520" y="1691640"/>
-            <a:ext cx="6217920" cy="3931920"/>
+            <a:ext cx="5486400" cy="3931920"/>
           </a:xfrm>
           <a:prstGeom prst="roundRect">
             <a:avLst/>
@@ -4171,8 +4171,8 @@
         </p:blipFill>
         <p:spPr>
           <a:xfrm>
-            <a:off x="7132320" y="1691640"/>
-            <a:ext cx="4327855" cy="3017520"/>
+            <a:off x="6492240" y="1691640"/>
+            <a:ext cx="4967935" cy="3429000"/>
           </a:xfrm>
           <a:prstGeom prst="rect">
             <a:avLst/>
@@ -4187,8 +4187,8 @@
         </p:nvSpPr>
         <p:spPr>
           <a:xfrm>
-            <a:off x="7132320" y="4846320"/>
-            <a:ext cx="4327855" cy="777240"/>
+            <a:off x="6492240" y="5166360"/>
+            <a:ext cx="4967935" cy="502920"/>
           </a:xfrm>
           <a:prstGeom prst="roundRect">
             <a:avLst/>
@@ -5628,7 +5628,7 @@
         <p:spPr>
           <a:xfrm>
             <a:off x="731520" y="1691640"/>
-            <a:ext cx="6217920" cy="3931920"/>
+            <a:ext cx="5486400" cy="3931920"/>
           </a:xfrm>
           <a:prstGeom prst="roundRect">
             <a:avLst/>
@@ -5689,8 +5689,8 @@
         </p:blipFill>
         <p:spPr>
           <a:xfrm>
-            <a:off x="7132320" y="1691640"/>
-            <a:ext cx="4327855" cy="3017520"/>
+            <a:off x="6492240" y="1691640"/>
+            <a:ext cx="4967935" cy="3429000"/>
           </a:xfrm>
           <a:prstGeom prst="rect">
             <a:avLst/>
@@ -5705,8 +5705,8 @@
         </p:nvSpPr>
         <p:spPr>
           <a:xfrm>
-            <a:off x="7132320" y="4846320"/>
-            <a:ext cx="4327855" cy="777240"/>
+            <a:off x="6492240" y="5166360"/>
+            <a:ext cx="4967935" cy="502920"/>
           </a:xfrm>
           <a:prstGeom prst="roundRect">
             <a:avLst/>
@@ -6003,7 +6003,7 @@
         <p:spPr>
           <a:xfrm>
             <a:off x="731520" y="1691640"/>
-            <a:ext cx="6217920" cy="3931920"/>
+            <a:ext cx="5486400" cy="3931920"/>
           </a:xfrm>
           <a:prstGeom prst="roundRect">
             <a:avLst/>
@@ -6094,8 +6094,8 @@
         </p:blipFill>
         <p:spPr>
           <a:xfrm>
-            <a:off x="7132320" y="1691640"/>
-            <a:ext cx="4327855" cy="3017520"/>
+            <a:off x="6492240" y="1691640"/>
+            <a:ext cx="4967935" cy="3429000"/>
           </a:xfrm>
           <a:prstGeom prst="rect">
             <a:avLst/>
@@ -6110,8 +6110,8 @@
         </p:nvSpPr>
         <p:spPr>
           <a:xfrm>
-            <a:off x="7132320" y="4846320"/>
-            <a:ext cx="4327855" cy="777240"/>
+            <a:off x="6492240" y="5166360"/>
+            <a:ext cx="4967935" cy="502920"/>
           </a:xfrm>
           <a:prstGeom prst="roundRect">
             <a:avLst/>
@@ -6408,7 +6408,7 @@
         <p:spPr>
           <a:xfrm>
             <a:off x="731520" y="1691640"/>
-            <a:ext cx="6217920" cy="3931920"/>
+            <a:ext cx="5486400" cy="3931920"/>
           </a:xfrm>
           <a:prstGeom prst="roundRect">
             <a:avLst/>
@@ -6469,8 +6469,8 @@
         </p:blipFill>
         <p:spPr>
           <a:xfrm>
-            <a:off x="7132320" y="1691640"/>
-            <a:ext cx="4327855" cy="3017520"/>
+            <a:off x="6492240" y="1691640"/>
+            <a:ext cx="4967935" cy="3429000"/>
           </a:xfrm>
           <a:prstGeom prst="rect">
             <a:avLst/>
@@ -6485,8 +6485,8 @@
         </p:nvSpPr>
         <p:spPr>
           <a:xfrm>
-            <a:off x="7132320" y="4846320"/>
-            <a:ext cx="4327855" cy="777240"/>
+            <a:off x="6492240" y="5166360"/>
+            <a:ext cx="4967935" cy="502920"/>
           </a:xfrm>
           <a:prstGeom prst="roundRect">
             <a:avLst/>
@@ -7545,7 +7545,7 @@
         <p:spPr>
           <a:xfrm>
             <a:off x="731520" y="1691640"/>
-            <a:ext cx="6217920" cy="3931920"/>
+            <a:ext cx="5486400" cy="3931920"/>
           </a:xfrm>
           <a:prstGeom prst="roundRect">
             <a:avLst/>
@@ -7666,8 +7666,8 @@
         </p:blipFill>
         <p:spPr>
           <a:xfrm>
-            <a:off x="7132320" y="1691640"/>
-            <a:ext cx="4327855" cy="3017520"/>
+            <a:off x="6492240" y="1691640"/>
+            <a:ext cx="4967935" cy="3429000"/>
           </a:xfrm>
           <a:prstGeom prst="rect">
             <a:avLst/>
@@ -7682,8 +7682,8 @@
         </p:nvSpPr>
         <p:spPr>
           <a:xfrm>
-            <a:off x="7132320" y="4846320"/>
-            <a:ext cx="4327855" cy="777240"/>
+            <a:off x="6492240" y="5166360"/>
+            <a:ext cx="4967935" cy="502920"/>
           </a:xfrm>
           <a:prstGeom prst="roundRect">
             <a:avLst/>
@@ -7980,7 +7980,7 @@
         <p:spPr>
           <a:xfrm>
             <a:off x="731520" y="1691640"/>
-            <a:ext cx="6217920" cy="3931920"/>
+            <a:ext cx="5486400" cy="3931920"/>
           </a:xfrm>
           <a:prstGeom prst="roundRect">
             <a:avLst/>
@@ -8041,8 +8041,8 @@
         </p:blipFill>
         <p:spPr>
           <a:xfrm>
-            <a:off x="7132320" y="1691640"/>
-            <a:ext cx="4327855" cy="3017520"/>
+            <a:off x="6492240" y="1691640"/>
+            <a:ext cx="4967935" cy="3429000"/>
           </a:xfrm>
           <a:prstGeom prst="rect">
             <a:avLst/>
@@ -8057,8 +8057,8 @@
         </p:nvSpPr>
         <p:spPr>
           <a:xfrm>
-            <a:off x="7132320" y="4846320"/>
-            <a:ext cx="4327855" cy="777240"/>
+            <a:off x="6492240" y="5166360"/>
+            <a:ext cx="4967935" cy="502920"/>
           </a:xfrm>
           <a:prstGeom prst="roundRect">
             <a:avLst/>
@@ -9534,7 +9534,7 @@
         <p:spPr>
           <a:xfrm>
             <a:off x="731520" y="1691640"/>
-            <a:ext cx="6217920" cy="3931920"/>
+            <a:ext cx="5486400" cy="3931920"/>
           </a:xfrm>
           <a:prstGeom prst="roundRect">
             <a:avLst/>
@@ -9670,8 +9670,8 @@
         </p:blipFill>
         <p:spPr>
           <a:xfrm>
-            <a:off x="7132320" y="1691640"/>
-            <a:ext cx="4327855" cy="3017520"/>
+            <a:off x="6492240" y="1691640"/>
+            <a:ext cx="4967935" cy="3429000"/>
           </a:xfrm>
           <a:prstGeom prst="rect">
             <a:avLst/>
@@ -9686,8 +9686,8 @@
         </p:nvSpPr>
         <p:spPr>
           <a:xfrm>
-            <a:off x="7132320" y="4846320"/>
-            <a:ext cx="4327855" cy="777240"/>
+            <a:off x="6492240" y="5166360"/>
+            <a:ext cx="4967935" cy="502920"/>
           </a:xfrm>
           <a:prstGeom prst="roundRect">
             <a:avLst/>
@@ -10326,7 +10326,7 @@
         <p:spPr>
           <a:xfrm>
             <a:off x="731520" y="1691640"/>
-            <a:ext cx="6217920" cy="3931920"/>
+            <a:ext cx="5486400" cy="3931920"/>
           </a:xfrm>
           <a:prstGeom prst="roundRect">
             <a:avLst/>
@@ -10432,8 +10432,8 @@
         </p:blipFill>
         <p:spPr>
           <a:xfrm>
-            <a:off x="7132320" y="1691640"/>
-            <a:ext cx="4327855" cy="3017520"/>
+            <a:off x="6492240" y="1691640"/>
+            <a:ext cx="4967935" cy="3429000"/>
           </a:xfrm>
           <a:prstGeom prst="rect">
             <a:avLst/>
@@ -10448,8 +10448,8 @@
         </p:nvSpPr>
         <p:spPr>
           <a:xfrm>
-            <a:off x="7132320" y="4846320"/>
-            <a:ext cx="4327855" cy="777240"/>
+            <a:off x="6492240" y="5166360"/>
+            <a:ext cx="4967935" cy="502920"/>
           </a:xfrm>
           <a:prstGeom prst="roundRect">
             <a:avLst/>
@@ -11157,7 +11157,7 @@
         <p:spPr>
           <a:xfrm>
             <a:off x="731520" y="1691640"/>
-            <a:ext cx="6217920" cy="3931920"/>
+            <a:ext cx="5486400" cy="3931920"/>
           </a:xfrm>
           <a:prstGeom prst="roundRect">
             <a:avLst/>
@@ -11218,8 +11218,8 @@
         </p:blipFill>
         <p:spPr>
           <a:xfrm>
-            <a:off x="7132320" y="1691640"/>
-            <a:ext cx="4327855" cy="3017520"/>
+            <a:off x="6492240" y="1691640"/>
+            <a:ext cx="4967935" cy="3429000"/>
           </a:xfrm>
           <a:prstGeom prst="rect">
             <a:avLst/>
@@ -11234,8 +11234,8 @@
         </p:nvSpPr>
         <p:spPr>
           <a:xfrm>
-            <a:off x="7132320" y="4846320"/>
-            <a:ext cx="4327855" cy="777240"/>
+            <a:off x="6492240" y="5166360"/>
+            <a:ext cx="4967935" cy="502920"/>
           </a:xfrm>
           <a:prstGeom prst="roundRect">
             <a:avLst/>

</xml_diff>

<commit_message>
feat: enlarge slide diagrams with high-res TrueType typography, full-width expand toggle, zoom modal, and Slide 2 comparison diagram
</commit_message>
<xml_diff>
--- a/CICD_Masterclass_20_Slides.pptx
+++ b/CICD_Masterclass_20_Slides.pptx
@@ -8652,7 +8652,7 @@
         <p:spPr>
           <a:xfrm>
             <a:off x="731520" y="1691640"/>
-            <a:ext cx="10728655" cy="3931920"/>
+            <a:ext cx="5486400" cy="3931920"/>
           </a:xfrm>
           <a:prstGeom prst="roundRect">
             <a:avLst/>
@@ -8742,26 +8742,50 @@
           </a:p>
         </p:txBody>
       </p:sp>
-      <p:sp>
-        <p:nvSpPr>
-          <p:cNvPr id="7" name="Rounded Rectangle 6"/>
+      <p:pic>
+        <p:nvPicPr>
+          <p:cNvPr id="7" name="Picture 6" descr="slide_2.png"/>
+          <p:cNvPicPr>
+            <a:picLocks noChangeAspect="1"/>
+          </p:cNvPicPr>
+          <p:nvPr/>
+        </p:nvPicPr>
+        <p:blipFill>
+          <a:blip r:embed="rId2"/>
+          <a:stretch>
+            <a:fillRect/>
+          </a:stretch>
+        </p:blipFill>
+        <p:spPr>
+          <a:xfrm>
+            <a:off x="6492240" y="1691640"/>
+            <a:ext cx="4967935" cy="3429000"/>
+          </a:xfrm>
+          <a:prstGeom prst="rect">
+            <a:avLst/>
+          </a:prstGeom>
+        </p:spPr>
+      </p:pic>
+      <p:sp>
+        <p:nvSpPr>
+          <p:cNvPr id="8" name="Rounded Rectangle 7"/>
           <p:cNvSpPr/>
           <p:nvPr/>
         </p:nvSpPr>
         <p:spPr>
           <a:xfrm>
-            <a:off x="7132320" y="1691640"/>
-            <a:ext cx="4327855" cy="3931920"/>
+            <a:off x="6492240" y="5166360"/>
+            <a:ext cx="4967935" cy="502920"/>
           </a:xfrm>
           <a:prstGeom prst="roundRect">
             <a:avLst/>
           </a:prstGeom>
           <a:solidFill>
-            <a:srgbClr val="FEFCF6"/>
-          </a:solidFill>
-          <a:ln w="19050">
+            <a:srgbClr val="F0F9FF"/>
+          </a:solidFill>
+          <a:ln w="12700">
             <a:solidFill>
-              <a:srgbClr val="D97706"/>
+              <a:srgbClr val="2563EB"/>
             </a:solidFill>
           </a:ln>
         </p:spPr>
@@ -8780,55 +8804,25 @@
           </a:fontRef>
         </p:style>
         <p:txBody>
-          <a:bodyPr rtlCol="0" anchor="ctr" wrap="square" tIns="182880" lIns="228600" rIns="228600"/>
+          <a:bodyPr rtlCol="0" anchor="ctr" wrap="square"/>
           <a:lstStyle/>
           <a:p>
             <a:pPr algn="ctr">
-              <a:defRPr sz="1100" b="1">
-                <a:solidFill>
-                  <a:srgbClr val="D97706"/>
-                </a:solidFill>
-              </a:defRPr>
-            </a:pPr>
-            <a:r>
-              <a:t>FOOD-ORDERING ANALOGY</a:t>
-            </a:r>
-          </a:p>
-          <a:p>
-            <a:pPr>
-              <a:spcBef>
-                <a:spcPts val="300"/>
-              </a:spcBef>
-              <a:defRPr sz="1300" b="1">
-                <a:solidFill>
-                  <a:srgbClr val="0F172A"/>
-                </a:solidFill>
-              </a:defRPr>
-            </a:pPr>
-            <a:r>
-              <a:t>The Manual Kitchen Analogy </a:t>
-            </a:r>
-          </a:p>
-          <a:p>
-            <a:pPr>
-              <a:spcBef>
-                <a:spcPts val="300"/>
-              </a:spcBef>
-              <a:defRPr sz="1150">
+              <a:defRPr sz="950">
                 <a:solidFill>
                   <a:srgbClr val="334155"/>
                 </a:solidFill>
               </a:defRPr>
             </a:pPr>
             <a:r>
-              <a:t>Imagine a restaurant where the cashier writes orders on paper, walks to the kitchen, checks every dish personally, packs each order, and calls a delivery rider manually.</a:t>
-            </a:r>
-          </a:p>
-        </p:txBody>
-      </p:sp>
-      <p:sp>
-        <p:nvSpPr>
-          <p:cNvPr id="8" name="Rounded Rectangle 7"/>
+              <a:t>Architecture Diagram: Manual Delivery 'Integration Hell' vs. Automated CI/CD Continuous Flow Comparison.</a:t>
+            </a:r>
+          </a:p>
+        </p:txBody>
+      </p:sp>
+      <p:sp>
+        <p:nvSpPr>
+          <p:cNvPr id="9" name="Rounded Rectangle 8"/>
           <p:cNvSpPr/>
           <p:nvPr/>
         </p:nvSpPr>

</xml_diff>

<commit_message>
feat: add comprehensive AWS cloud deployment architecture, services, and diagrams to masterclass
</commit_message>
<xml_diff>
--- a/CICD_Masterclass_20_Slides.pptx
+++ b/CICD_Masterclass_20_Slides.pptx
@@ -6451,6 +6451,81 @@
               <a:t>CORE CURRICULUM &amp; PRINCIPLES</a:t>
             </a:r>
           </a:p>
+          <a:p>
+            <a:pPr>
+              <a:spcBef>
+                <a:spcPts val="400"/>
+              </a:spcBef>
+              <a:defRPr sz="1150">
+                <a:solidFill>
+                  <a:srgbClr val="334155"/>
+                </a:solidFill>
+              </a:defRPr>
+            </a:pPr>
+            <a:r>
+              <a:t>• AWS Cloud Infrastructure: Provides high-availability compute, container orchestration, and automated auto-scaling for modern microservices.</a:t>
+            </a:r>
+          </a:p>
+          <a:p>
+            <a:pPr>
+              <a:spcBef>
+                <a:spcPts val="400"/>
+              </a:spcBef>
+              <a:defRPr sz="1150">
+                <a:solidFill>
+                  <a:srgbClr val="334155"/>
+                </a:solidFill>
+              </a:defRPr>
+            </a:pPr>
+            <a:r>
+              <a:t>• Keyless OIDC Authentication: GitHub Actions assumes an IAM Role via OpenID Connect (OIDC), eliminating the dangerous need for stored static access keys.</a:t>
+            </a:r>
+          </a:p>
+          <a:p>
+            <a:pPr>
+              <a:spcBef>
+                <a:spcPts val="400"/>
+              </a:spcBef>
+              <a:defRPr sz="1150">
+                <a:solidFill>
+                  <a:srgbClr val="334155"/>
+                </a:solidFill>
+              </a:defRPr>
+            </a:pPr>
+            <a:r>
+              <a:t>• Amazon ECR (Elastic Container Registry): Private, encrypted Docker image registry that automatically scans every container image for CVE vulnerabilities on push.</a:t>
+            </a:r>
+          </a:p>
+          <a:p>
+            <a:pPr>
+              <a:spcBef>
+                <a:spcPts val="400"/>
+              </a:spcBef>
+              <a:defRPr sz="1150">
+                <a:solidFill>
+                  <a:srgbClr val="334155"/>
+                </a:solidFill>
+              </a:defRPr>
+            </a:pPr>
+            <a:r>
+              <a:t>• Amazon ECS (Elastic Container Service): Serverless container orchestration using AWS Fargate that launches and manages tasks without managing EC2 servers.</a:t>
+            </a:r>
+          </a:p>
+          <a:p>
+            <a:pPr>
+              <a:spcBef>
+                <a:spcPts val="400"/>
+              </a:spcBef>
+              <a:defRPr sz="1150">
+                <a:solidFill>
+                  <a:srgbClr val="334155"/>
+                </a:solidFill>
+              </a:defRPr>
+            </a:pPr>
+            <a:r>
+              <a:t>• Application Load Balancer (ALB): Distributes traffic across multi-AZ container tasks, conducts continuous /health checks, and shifts traffic with zero downtime.</a:t>
+            </a:r>
+          </a:p>
         </p:txBody>
       </p:sp>
       <p:pic>
@@ -6526,7 +6601,7 @@
               </a:defRPr>
             </a:pPr>
             <a:r>
-              <a:t>Architecture Diagram: AWS Cloud Deployment: GitHub Actions OIDC ➔ Amazon ECR Registry ➔ Amazon ECS High-Availability Clusters.</a:t>
+              <a:t>Architecture Diagram: AWS Cloud Architecture: GitHub Actions OIDC ➔ Amazon ECR Registry ➔ Amazon ECS Fargate ➔ ALB Load Balancer (200 OK).</a:t>
             </a:r>
           </a:p>
         </p:txBody>
@@ -8023,6 +8098,81 @@
               <a:t>CORE CURRICULUM &amp; PRINCIPLES</a:t>
             </a:r>
           </a:p>
+          <a:p>
+            <a:pPr>
+              <a:spcBef>
+                <a:spcPts val="400"/>
+              </a:spcBef>
+              <a:defRPr sz="1150">
+                <a:solidFill>
+                  <a:srgbClr val="334155"/>
+                </a:solidFill>
+              </a:defRPr>
+            </a:pPr>
+            <a:r>
+              <a:t>• End-to-End Real World Pipeline: From Git commit to live production cloud on AWS in under 4 minutes.</a:t>
+            </a:r>
+          </a:p>
+          <a:p>
+            <a:pPr>
+              <a:spcBef>
+                <a:spcPts val="400"/>
+              </a:spcBef>
+              <a:defRPr sz="1150">
+                <a:solidFill>
+                  <a:srgbClr val="334155"/>
+                </a:solidFill>
+              </a:defRPr>
+            </a:pPr>
+            <a:r>
+              <a:t>• Automated CI Gates: Code linting, type-checking, and 80%+ test coverage enforced before any container image is compiled.</a:t>
+            </a:r>
+          </a:p>
+          <a:p>
+            <a:pPr>
+              <a:spcBef>
+                <a:spcPts val="400"/>
+              </a:spcBef>
+              <a:defRPr sz="1150">
+                <a:solidFill>
+                  <a:srgbClr val="334155"/>
+                </a:solidFill>
+              </a:defRPr>
+            </a:pPr>
+            <a:r>
+              <a:t>• Immutable Packaging: Docker multi-stage build creates a tiny, secure container image pushed directly to Amazon ECR.</a:t>
+            </a:r>
+          </a:p>
+          <a:p>
+            <a:pPr>
+              <a:spcBef>
+                <a:spcPts val="400"/>
+              </a:spcBef>
+              <a:defRPr sz="1150">
+                <a:solidFill>
+                  <a:srgbClr val="334155"/>
+                </a:solidFill>
+              </a:defRPr>
+            </a:pPr>
+            <a:r>
+              <a:t>• Zero-Downtime Deployment: Amazon ECS rolls out new tasks using rolling updates or blue-green switching via the Application Load Balancer.</a:t>
+            </a:r>
+          </a:p>
+          <a:p>
+            <a:pPr>
+              <a:spcBef>
+                <a:spcPts val="400"/>
+              </a:spcBef>
+              <a:defRPr sz="1150">
+                <a:solidFill>
+                  <a:srgbClr val="334155"/>
+                </a:solidFill>
+              </a:defRPr>
+            </a:pPr>
+            <a:r>
+              <a:t>• SRE Telemetry &amp; Observability: AWS CloudWatch tracks latency and 5xx error rates, triggering automated rollbacks if any defects emerge.</a:t>
+            </a:r>
+          </a:p>
         </p:txBody>
       </p:sp>
       <p:pic>
@@ -8098,7 +8248,7 @@
               </a:defRPr>
             </a:pPr>
             <a:r>
-              <a:t>Architecture Diagram: End-to-End Real-World Project: Automated Food Ordering App pipeline running on GitHub Actions and AWS.</a:t>
+              <a:t>Architecture Diagram: End-to-End Real-World Project: Automated Food Ordering App pipeline running on GitHub Actions, Docker, and AWS.</a:t>
             </a:r>
           </a:p>
         </p:txBody>
@@ -8152,7 +8302,7 @@
               </a:defRPr>
             </a:pPr>
             <a:r>
-              <a:t>KEY TAKEAWAY: This end-to-end project combines code, CI/CD, containers, cloud infrastructure, and monitoring into a complete production system.</a:t>
+              <a:t>KEY TAKEAWAY: This end-to-end project combines code, CI/CD, containers, AWS cloud infrastructure, and monitoring into a complete production system.</a:t>
             </a:r>
           </a:p>
         </p:txBody>

</xml_diff>